<commit_message>
OMG. Put back web.infrastructure redirect
</commit_message>
<xml_diff>
--- a/docs/presentations/Sage300SDK_2026_0WebSDKOverview.pptx
+++ b/docs/presentations/Sage300SDK_2026_0WebSDKOverview.pptx
@@ -3618,7 +3618,7 @@
           <a:p>
             <a:fld id="{EC0ECC91-7099-9546-9775-79C77D0DA930}" type="datetimeFigureOut">
               <a:rPr lang="en-US" smtClean="0"/>
-              <a:t>10/20/2025</a:t>
+              <a:t>11/10/2025</a:t>
             </a:fld>
             <a:endParaRPr lang="en-US"/>
           </a:p>
@@ -8949,8 +8949,12 @@
           </a:p>
           <a:p>
             <a:r>
+              <a:rPr lang="en-US"/>
+              <a:t>November </a:t>
+            </a:r>
+            <a:r>
               <a:rPr lang="en-US" dirty="0"/>
-              <a:t>October 2025</a:t>
+              <a:t>2025</a:t>
             </a:r>
           </a:p>
         </p:txBody>
@@ -18518,7 +18522,7 @@
         <p:spPr>
           <a:xfrm>
             <a:off x="411479" y="1347300"/>
-            <a:ext cx="5181454" cy="3416320"/>
+            <a:ext cx="5181454" cy="4247317"/>
           </a:xfrm>
           <a:prstGeom prst="rect">
             <a:avLst/>
@@ -18588,6 +18592,20 @@
             <a:r>
               <a:rPr lang="en-US" dirty="0"/>
               <a:t>See tester in src/utilities folder</a:t>
+            </a:r>
+          </a:p>
+          <a:p>
+            <a:pPr marL="285750" indent="-285750">
+              <a:buFont typeface="Arial" panose="020B0604020202020204" pitchFamily="34" charset="0"/>
+              <a:buChar char="•"/>
+            </a:pPr>
+            <a:r>
+              <a:rPr lang="en-US" dirty="0">
+                <a:solidFill>
+                  <a:srgbClr val="FF0000"/>
+                </a:solidFill>
+              </a:rPr>
+              <a:t>Note: A new web.config entry has been created that controls whether https is required. See document for further information.</a:t>
             </a:r>
           </a:p>
         </p:txBody>

</xml_diff>